<commit_message>
fixed build issue, updted demo slide
</commit_message>
<xml_diff>
--- a/docs/presentation/firewatch-ai-pitch-deck.pptx
+++ b/docs/presentation/firewatch-ai-pitch-deck.pptx
@@ -1776,6 +1776,144 @@
             </a:pPr>
             <a:r>
               <a:t>1:55–2:40. Walk through a recorded sample, the RGB and thermal outputs, and the quality flags. Explain what is missing rather than claiming an integrated live system. Use the backup recording if needed. Repository access and the final demo must be verified before presenting. Codex helped implementation and documentation. Independent annotation acceptance remains pending. Source: backend/vision/README.md.</a:t>
+            </a:r>
+            <a:endParaRPr>
+              <a:latin typeface="Plus Jakarta Sans"/>
+              <a:ea typeface="Plus Jakarta Sans"/>
+              <a:cs typeface="Plus Jakarta Sans"/>
+            </a:endParaRPr>
+          </a:p>
+          <a:p xmlns:a="http://schemas.openxmlformats.org/drawingml/2006/main">
+            <a:pPr marL="0" marR="0" lvl="0" indent="0" algn="l">
+              <a:lnSpc>
+                <a:spcPct val="100000"/>
+              </a:lnSpc>
+              <a:spcBef>
+                <a:spcPts val="0"/>
+              </a:spcBef>
+              <a:spcAft>
+                <a:spcPts val="0"/>
+              </a:spcAft>
+              <a:buSzPts val="1400"/>
+              <a:buNone/>
+            </a:pPr>
+            <a:r>
+              <a:t/>
+            </a:r>
+            <a:endParaRPr>
+              <a:latin typeface="Plus Jakarta Sans"/>
+              <a:ea typeface="Plus Jakarta Sans"/>
+              <a:cs typeface="Plus Jakarta Sans"/>
+            </a:endParaRPr>
+          </a:p>
+          <a:p xmlns:a="http://schemas.openxmlformats.org/drawingml/2006/main">
+            <a:pPr marL="0" marR="0" lvl="0" indent="0" algn="l">
+              <a:lnSpc>
+                <a:spcPct val="100000"/>
+              </a:lnSpc>
+              <a:spcBef>
+                <a:spcPts val="0"/>
+              </a:spcBef>
+              <a:spcAft>
+                <a:spcPts val="0"/>
+              </a:spcAft>
+              <a:buSzPts val="1400"/>
+              <a:buNone/>
+            </a:pPr>
+            <a:r>
+              <a:t/>
+            </a:r>
+            <a:endParaRPr>
+              <a:latin typeface="Plus Jakarta Sans"/>
+              <a:ea typeface="Plus Jakarta Sans"/>
+              <a:cs typeface="Plus Jakarta Sans"/>
+            </a:endParaRPr>
+          </a:p>
+          <a:p xmlns:a="http://schemas.openxmlformats.org/drawingml/2006/main">
+            <a:pPr marL="0" marR="0" lvl="0" indent="0" algn="l">
+              <a:lnSpc>
+                <a:spcPct val="100000"/>
+              </a:lnSpc>
+              <a:spcBef>
+                <a:spcPts val="0"/>
+              </a:spcBef>
+              <a:spcAft>
+                <a:spcPts val="0"/>
+              </a:spcAft>
+              <a:buSzPts val="1400"/>
+              <a:buNone/>
+            </a:pPr>
+            <a:r>
+              <a:t>TECH STACK, REPO &amp; CODEX/OPENAI TOOL USE</a:t>
+            </a:r>
+            <a:endParaRPr>
+              <a:latin typeface="Plus Jakarta Sans"/>
+              <a:ea typeface="Plus Jakarta Sans"/>
+              <a:cs typeface="Plus Jakarta Sans"/>
+            </a:endParaRPr>
+          </a:p>
+          <a:p xmlns:a="http://schemas.openxmlformats.org/drawingml/2006/main">
+            <a:pPr marL="0" marR="0" lvl="0" indent="0" algn="l">
+              <a:lnSpc>
+                <a:spcPct val="100000"/>
+              </a:lnSpc>
+              <a:spcBef>
+                <a:spcPts val="0"/>
+              </a:spcBef>
+              <a:spcAft>
+                <a:spcPts val="0"/>
+              </a:spcAft>
+              <a:buSzPts val="1400"/>
+              <a:buNone/>
+            </a:pPr>
+            <a:r>
+              <a:t>Built with React, TypeScript, Leaflet and Node.js/Fastify, with Python/scikit-learn for canopy estimation. Data: LANDFIRE, Sentinel-2, WorldCover, NASA FIRMS, NWS/Open-Meteo, OpenStreetMap and GOFER/WFIGS fire records. Codex assisted implementation, research, debugging and documentation; outputs were checked through automated tests, physics benchmarks, historical-fire comparisons and visual inspection.</a:t>
+            </a:r>
+            <a:endParaRPr>
+              <a:latin typeface="Plus Jakarta Sans"/>
+              <a:ea typeface="Plus Jakarta Sans"/>
+              <a:cs typeface="Plus Jakarta Sans"/>
+            </a:endParaRPr>
+          </a:p>
+          <a:p xmlns:a="http://schemas.openxmlformats.org/drawingml/2006/main">
+            <a:pPr marL="0" marR="0" lvl="0" indent="0" algn="l">
+              <a:lnSpc>
+                <a:spcPct val="100000"/>
+              </a:lnSpc>
+              <a:spcBef>
+                <a:spcPts val="0"/>
+              </a:spcBef>
+              <a:spcAft>
+                <a:spcPts val="0"/>
+              </a:spcAft>
+              <a:buSzPts val="1400"/>
+              <a:buNone/>
+            </a:pPr>
+            <a:r>
+              <a:t>Repository: https://github.com/RubSar/firewatch-ai. Local history checked on 2026-09-27: 54 commits, HEAD 6ab4918. Judge access remains unconfirmed because the GitHub access check could not resolve github.com. Local history does not confirm that all changes are pushed.</a:t>
+            </a:r>
+            <a:endParaRPr>
+              <a:latin typeface="Plus Jakarta Sans"/>
+              <a:ea typeface="Plus Jakarta Sans"/>
+              <a:cs typeface="Plus Jakarta Sans"/>
+            </a:endParaRPr>
+          </a:p>
+          <a:p xmlns:a="http://schemas.openxmlformats.org/drawingml/2006/main">
+            <a:pPr marL="0" marR="0" lvl="0" indent="0" algn="l">
+              <a:lnSpc>
+                <a:spcPct val="100000"/>
+              </a:lnSpc>
+              <a:spcBef>
+                <a:spcPts val="0"/>
+              </a:spcBef>
+              <a:spcAft>
+                <a:spcPts val="0"/>
+              </a:spcAft>
+              <a:buSzPts val="1400"/>
+              <a:buNone/>
+            </a:pPr>
+            <a:r>
+              <a:t>Sources: pitch.md sections 3, 4, 8, 9 and 10; frontend/package.json; frontend/api/package.json; docs/concurrent-analysis/09-historical-similarity/historical-preview.md; AGENTS.md; local Git log. Codex is a development tool here, not the wildfire spread model. Some research labels and extracted document facts still await independent human review.</a:t>
             </a:r>
             <a:endParaRPr>
               <a:latin typeface="Plus Jakarta Sans"/>
@@ -6898,6 +7036,17 @@
               <a:buNone/>
             </a:pPr>
             <a:r>
+              <a:rPr sz="1300" b="1" i="1" u="none" strike="noStrike" cap="none">
+                <a:solidFill>
+                  <a:srgbClr val="F86130"/>
+                </a:solidFill>
+                <a:latin typeface="Plus Jakarta Sans"/>
+                <a:ea typeface="Plus Jakarta Sans"/>
+                <a:cs typeface="Plus Jakarta Sans"/>
+              </a:rPr>
+              <a:t>Working today:</a:t>
+            </a:r>
+            <a:r>
               <a:rPr sz="1300" b="0" i="1" u="none" strike="noStrike" cap="none">
                 <a:solidFill>
                   <a:srgbClr val="F86130"/>
@@ -6906,7 +7055,7 @@
                 <a:ea typeface="Plus Jakarta Sans"/>
                 <a:cs typeface="Plus Jakarta Sans"/>
               </a:rPr>
-              <a:t>Runs: candidate masks and quality reports. Pending: geolocation, temporal tracking and live integration.</a:t>
+              <a:t> interactive simulation and historical-fire playback, with physics tests and comparisons against real wildfire data.</a:t>
             </a:r>
             <a:endParaRPr sz="1300" b="0" i="0" u="none" strike="noStrike" cap="none">
               <a:solidFill>
@@ -6916,6 +7065,47 @@
               <a:ea typeface="Plus Jakarta Sans"/>
               <a:cs typeface="Plus Jakarta Sans"/>
             </a:endParaRPr>
+          </a:p>
+          <a:p xmlns:a="http://schemas.openxmlformats.org/drawingml/2006/main">
+            <a:pPr marL="0" marR="0" lvl="0" indent="0" algn="l">
+              <a:lnSpc>
+                <a:spcPct val="100000"/>
+              </a:lnSpc>
+              <a:spcBef>
+                <a:spcPts val="0"/>
+              </a:spcBef>
+              <a:spcAft>
+                <a:spcPts val="0"/>
+              </a:spcAft>
+              <a:buClr>
+                <a:srgbClr val="F86130"/>
+              </a:buClr>
+              <a:buSzPts val="1300"/>
+              <a:buFont typeface="Inter"/>
+              <a:buNone/>
+            </a:pPr>
+            <a:r>
+              <a:rPr sz="1300" b="1" i="1" u="none" strike="noStrike" cap="none">
+                <a:solidFill>
+                  <a:srgbClr val="F86130"/>
+                </a:solidFill>
+                <a:latin typeface="Plus Jakarta Sans"/>
+                <a:ea typeface="Plus Jakarta Sans"/>
+                <a:cs typeface="Plus Jakarta Sans"/>
+              </a:rPr>
+              <a:t>Still experimental:</a:t>
+            </a:r>
+            <a:r>
+              <a:rPr sz="1300" b="0" i="1" u="none" strike="noStrike" cap="none">
+                <a:solidFill>
+                  <a:srgbClr val="F86130"/>
+                </a:solidFill>
+                <a:latin typeface="Plus Jakarta Sans"/>
+                <a:ea typeface="Plus Jakarta Sans"/>
+                <a:cs typeface="Plus Jakarta Sans"/>
+              </a:rPr>
+              <a:t> operational forecasts and suppression effectiveness.</a:t>
+            </a:r>
           </a:p>
         </p:txBody>
       </p:sp>
@@ -7566,7 +7756,7 @@
       </p:sp>
       <p:cxnSp>
         <p:nvCxnSpPr>
-          <p:cNvPr id="166" name="Google Shape;81;p6"/>
+          <p:cNvPr id="214" name="Google Shape;81;p6"/>
           <p:cNvCxnSpPr/>
           <p:nvPr/>
         </p:nvCxnSpPr>
@@ -7935,7 +8125,29 @@
                 <a:ea typeface="Plus Jakarta Sans"/>
                 <a:cs typeface="Plus Jakarta Sans"/>
               </a:rPr>
-              <a:t>Python, NumPy/Pillow, FLAME 2/3. React/TypeScript and Leaflet UI. Codex assists implementation and documentation. [Confirm demo tests, human review and judge repo access.]</a:t>
+              <a:t>React/TypeScript, Leaflet, Node.js/Fastify; Python/scikit-learn. </a:t>
+            </a:r>
+            <a:r>
+              <a:rPr sz="1100" b="1" i="1" u="none" strike="noStrike" cap="none">
+                <a:solidFill>
+                  <a:srgbClr val="F86130"/>
+                </a:solidFill>
+                <a:latin typeface="Plus Jakarta Sans"/>
+                <a:ea typeface="Plus Jakarta Sans"/>
+                <a:cs typeface="Plus Jakarta Sans"/>
+              </a:rPr>
+              <a:t>Data:</a:t>
+            </a:r>
+            <a:r>
+              <a:rPr sz="1100" b="0" i="1" u="none" strike="noStrike" cap="none">
+                <a:solidFill>
+                  <a:srgbClr val="F86130"/>
+                </a:solidFill>
+                <a:latin typeface="Plus Jakarta Sans"/>
+                <a:ea typeface="Plus Jakarta Sans"/>
+                <a:cs typeface="Plus Jakarta Sans"/>
+              </a:rPr>
+              <a:t> LANDFIRE, Sentinel-2, WorldCover, FIRMS, NWS/Open-Meteo, OSM, GOFER/WFIGS.</a:t>
             </a:r>
             <a:endParaRPr sz="1100" b="0" i="0" u="none" strike="noStrike" cap="none">
               <a:solidFill>
@@ -7945,6 +8157,69 @@
               <a:ea typeface="Plus Jakarta Sans"/>
               <a:cs typeface="Plus Jakarta Sans"/>
             </a:endParaRPr>
+          </a:p>
+          <a:p xmlns:a="http://schemas.openxmlformats.org/drawingml/2006/main">
+            <a:pPr marL="0" marR="0" lvl="0" indent="0" algn="l">
+              <a:lnSpc>
+                <a:spcPct val="100000"/>
+              </a:lnSpc>
+              <a:spcBef>
+                <a:spcPts val="0"/>
+              </a:spcBef>
+              <a:spcAft>
+                <a:spcPts val="0"/>
+              </a:spcAft>
+              <a:buClr>
+                <a:srgbClr val="F86130"/>
+              </a:buClr>
+              <a:buSzPts val="1100"/>
+              <a:buFont typeface="Inter"/>
+              <a:buNone/>
+            </a:pPr>
+            <a:r>
+              <a:rPr sz="1100" b="1" i="1" u="none" strike="noStrike" cap="none">
+                <a:solidFill>
+                  <a:srgbClr val="F86130"/>
+                </a:solidFill>
+                <a:latin typeface="Plus Jakarta Sans"/>
+                <a:ea typeface="Plus Jakarta Sans"/>
+                <a:cs typeface="Plus Jakarta Sans"/>
+              </a:rPr>
+              <a:t>Codex</a:t>
+            </a:r>
+            <a:r>
+              <a:rPr sz="1100" b="0" i="1" u="none" strike="noStrike" cap="none">
+                <a:solidFill>
+                  <a:srgbClr val="F86130"/>
+                </a:solidFill>
+                <a:latin typeface="Plus Jakarta Sans"/>
+                <a:ea typeface="Plus Jakarta Sans"/>
+                <a:cs typeface="Plus Jakarta Sans"/>
+              </a:rPr>
+              <a:t> assisted implementation, research, debugging and documentation. </a:t>
+            </a:r>
+            <a:r>
+              <a:rPr sz="1100" b="1" i="1" u="none" strike="noStrike" cap="none">
+                <a:solidFill>
+                  <a:srgbClr val="F86130"/>
+                </a:solidFill>
+                <a:latin typeface="Plus Jakarta Sans"/>
+                <a:ea typeface="Plus Jakarta Sans"/>
+                <a:cs typeface="Plus Jakarta Sans"/>
+              </a:rPr>
+              <a:t>Checks:</a:t>
+            </a:r>
+            <a:r>
+              <a:rPr sz="1100" b="0" i="1" u="none" strike="noStrike" cap="none">
+                <a:solidFill>
+                  <a:srgbClr val="F86130"/>
+                </a:solidFill>
+                <a:latin typeface="Plus Jakarta Sans"/>
+                <a:ea typeface="Plus Jakarta Sans"/>
+                <a:cs typeface="Plus Jakarta Sans"/>
+              </a:rPr>
+              <a:t> tests, physics benchmarks, historical-fire comparisons and visual inspection.</a:t>
+            </a:r>
           </a:p>
         </p:txBody>
       </p:sp>

</xml_diff>